<commit_message>
Remove translucent scrim overlays and add badges to slide 2
The semi-transparent rectangles blending image edges into the
background on slides 1 and 8 rendered as a visible brown band in
PowerPoint instead of a smooth blend, so they're removed. Slide 2 now
uses square numbered badges and a short tagline for more visual
structure.

Co-Authored-By: Claude Sonnet 5 <noreply@anthropic.com>
Claude-Session: https://claude.ai/code/session_01PJ4fJb98xC4aTyW7LXohs3
</commit_message>
<xml_diff>
--- a/Cacau_Raro_Percepcao_Consumidor.pptx
+++ b/Cacau_Raro_Percepcao_Consumidor.pptx
@@ -1523,29 +1523,7 @@
       </p:pic>
       <p:sp>
         <p:nvSpPr>
-          <p:cNvPr id="3" name="Shape 0"/>
-          <p:cNvSpPr/>
-          <p:nvPr/>
-        </p:nvSpPr>
-        <p:spPr>
-          <a:xfrm>
-            <a:off x="6903720" y="0"/>
-            <a:ext cx="457200" cy="6858000"/>
-          </a:xfrm>
-          <a:prstGeom prst="rect">
-            <a:avLst/>
-          </a:prstGeom>
-          <a:solidFill>
-            <a:srgbClr val="17110D">
-              <a:alpha val="85000"/>
-            </a:srgbClr>
-          </a:solidFill>
-          <a:ln/>
-        </p:spPr>
-      </p:sp>
-      <p:sp>
-        <p:nvSpPr>
-          <p:cNvPr id="4" name="Text 1"/>
+          <p:cNvPr id="3" name="Text 0"/>
           <p:cNvSpPr txBox="1"/>
           <p:nvPr/>
         </p:nvSpPr>
@@ -1584,7 +1562,7 @@
       </p:sp>
       <p:sp>
         <p:nvSpPr>
-          <p:cNvPr id="5" name="Text 2"/>
+          <p:cNvPr id="4" name="Text 1"/>
           <p:cNvSpPr txBox="1"/>
           <p:nvPr/>
         </p:nvSpPr>
@@ -1623,7 +1601,7 @@
       </p:sp>
       <p:sp>
         <p:nvSpPr>
-          <p:cNvPr id="6" name="Text 3"/>
+          <p:cNvPr id="5" name="Text 2"/>
           <p:cNvSpPr txBox="1"/>
           <p:nvPr/>
         </p:nvSpPr>
@@ -1662,7 +1640,7 @@
       </p:sp>
       <p:sp>
         <p:nvSpPr>
-          <p:cNvPr id="7" name="Text 4"/>
+          <p:cNvPr id="6" name="Text 3"/>
           <p:cNvSpPr txBox="1"/>
           <p:nvPr/>
         </p:nvSpPr>
@@ -1834,57 +1812,140 @@
       </p:sp>
       <p:sp>
         <p:nvSpPr>
-          <p:cNvPr id="4" name="Shape 2"/>
-          <p:cNvSpPr/>
-          <p:nvPr/>
-        </p:nvSpPr>
-        <p:spPr>
-          <a:xfrm>
-            <a:off x="640080" y="2103120"/>
-            <a:ext cx="118872" cy="118872"/>
-          </a:xfrm>
-          <a:prstGeom prst="rect">
-            <a:avLst/>
-          </a:prstGeom>
-          <a:solidFill>
-            <a:srgbClr val="C6A15B"/>
-          </a:solidFill>
-          <a:ln/>
-        </p:spPr>
-      </p:sp>
-      <p:sp>
-        <p:nvSpPr>
-          <p:cNvPr id="5" name="Text 3"/>
-          <p:cNvSpPr txBox="1"/>
-          <p:nvPr/>
-        </p:nvSpPr>
-        <p:spPr>
-          <a:xfrm>
-            <a:off x="960120" y="1938528"/>
-            <a:ext cx="4800600" cy="365760"/>
-          </a:xfrm>
-          <a:prstGeom prst="rect">
-            <a:avLst/>
-          </a:prstGeom>
-          <a:noFill/>
-          <a:ln/>
-        </p:spPr>
-        <p:txBody>
-          <a:bodyPr wrap="square" lIns="0" tIns="0" rIns="0" bIns="0" rtlCol="0" anchor="ctr"/>
-          <a:lstStyle/>
-          <a:p>
-            <a:pPr indent="0" marL="0">
-              <a:buNone/>
-            </a:pPr>
-            <a:r>
-              <a:rPr lang="en-US" sz="1800" b="1" dirty="0">
-                <a:solidFill>
-                  <a:srgbClr val="EFE6D8"/>
+          <p:cNvPr id="4" name="Text 2"/>
+          <p:cNvSpPr txBox="1"/>
+          <p:nvPr/>
+        </p:nvSpPr>
+        <p:spPr>
+          <a:xfrm>
+            <a:off x="640080" y="1508760"/>
+            <a:ext cx="5120640" cy="365760"/>
+          </a:xfrm>
+          <a:prstGeom prst="rect">
+            <a:avLst/>
+          </a:prstGeom>
+          <a:noFill/>
+          <a:ln/>
+        </p:spPr>
+        <p:txBody>
+          <a:bodyPr wrap="square" lIns="0" tIns="0" rIns="0" bIns="0" rtlCol="0" anchor="ctr"/>
+          <a:lstStyle/>
+          <a:p>
+            <a:pPr indent="0" marL="0">
+              <a:buNone/>
+            </a:pPr>
+            <a:r>
+              <a:rPr lang="en-US" sz="1400" i="1" dirty="0">
+                <a:solidFill>
+                  <a:srgbClr val="C6A15B"/>
                 </a:solidFill>
                 <a:latin typeface="Cambria" pitchFamily="34" charset="0"/>
                 <a:ea typeface="Cambria" pitchFamily="34" charset="-122"/>
                 <a:cs typeface="Cambria" pitchFamily="34" charset="-120"/>
               </a:rPr>
+              <a:t>Cinco decisões, um único conceito.</a:t>
+            </a:r>
+            <a:endParaRPr lang="en-US" sz="1400" dirty="0"/>
+          </a:p>
+        </p:txBody>
+      </p:sp>
+      <p:sp>
+        <p:nvSpPr>
+          <p:cNvPr id="5" name="Shape 3"/>
+          <p:cNvSpPr/>
+          <p:nvPr/>
+        </p:nvSpPr>
+        <p:spPr>
+          <a:xfrm>
+            <a:off x="640080" y="2148840"/>
+            <a:ext cx="548640" cy="548640"/>
+          </a:xfrm>
+          <a:prstGeom prst="rect">
+            <a:avLst/>
+          </a:prstGeom>
+          <a:solidFill>
+            <a:srgbClr val="3C2A1C"/>
+          </a:solidFill>
+          <a:ln w="12700">
+            <a:solidFill>
+              <a:srgbClr val="9C7C3F"/>
+            </a:solidFill>
+            <a:prstDash val="solid"/>
+          </a:ln>
+        </p:spPr>
+      </p:sp>
+      <p:sp>
+        <p:nvSpPr>
+          <p:cNvPr id="6" name="Text 4"/>
+          <p:cNvSpPr txBox="1"/>
+          <p:nvPr/>
+        </p:nvSpPr>
+        <p:spPr>
+          <a:xfrm>
+            <a:off x="640080" y="2148840"/>
+            <a:ext cx="548640" cy="548640"/>
+          </a:xfrm>
+          <a:prstGeom prst="rect">
+            <a:avLst/>
+          </a:prstGeom>
+          <a:noFill/>
+          <a:ln/>
+        </p:spPr>
+        <p:txBody>
+          <a:bodyPr wrap="square" lIns="0" tIns="0" rIns="0" bIns="0" rtlCol="0" anchor="ctr"/>
+          <a:lstStyle/>
+          <a:p>
+            <a:pPr algn="ctr" indent="0" marL="0">
+              <a:buNone/>
+            </a:pPr>
+            <a:r>
+              <a:rPr lang="en-US" sz="1500" b="1" dirty="0">
+                <a:solidFill>
+                  <a:srgbClr val="C6A15B"/>
+                </a:solidFill>
+                <a:latin typeface="Cambria" pitchFamily="34" charset="0"/>
+                <a:ea typeface="Cambria" pitchFamily="34" charset="-122"/>
+                <a:cs typeface="Cambria" pitchFamily="34" charset="-120"/>
+              </a:rPr>
+              <a:t>01</a:t>
+            </a:r>
+            <a:endParaRPr lang="en-US" sz="1500" dirty="0"/>
+          </a:p>
+        </p:txBody>
+      </p:sp>
+      <p:sp>
+        <p:nvSpPr>
+          <p:cNvPr id="7" name="Text 5"/>
+          <p:cNvSpPr txBox="1"/>
+          <p:nvPr/>
+        </p:nvSpPr>
+        <p:spPr>
+          <a:xfrm>
+            <a:off x="1417320" y="2093976"/>
+            <a:ext cx="4343400" cy="365760"/>
+          </a:xfrm>
+          <a:prstGeom prst="rect">
+            <a:avLst/>
+          </a:prstGeom>
+          <a:noFill/>
+          <a:ln/>
+        </p:spPr>
+        <p:txBody>
+          <a:bodyPr wrap="square" lIns="0" tIns="0" rIns="0" bIns="0" rtlCol="0" anchor="ctr"/>
+          <a:lstStyle/>
+          <a:p>
+            <a:pPr indent="0" marL="0">
+              <a:buNone/>
+            </a:pPr>
+            <a:r>
+              <a:rPr lang="en-US" sz="1800" b="1" dirty="0">
+                <a:solidFill>
+                  <a:srgbClr val="EFE6D8"/>
+                </a:solidFill>
+                <a:latin typeface="Cambria" pitchFamily="34" charset="0"/>
+                <a:ea typeface="Cambria" pitchFamily="34" charset="-122"/>
+                <a:cs typeface="Cambria" pitchFamily="34" charset="-120"/>
+              </a:rPr>
               <a:t>Material</a:t>
             </a:r>
             <a:endParaRPr lang="en-US" sz="1800" dirty="0"/>
@@ -1893,14 +1954,14 @@
       </p:sp>
       <p:sp>
         <p:nvSpPr>
-          <p:cNvPr id="6" name="Text 4"/>
-          <p:cNvSpPr txBox="1"/>
-          <p:nvPr/>
-        </p:nvSpPr>
-        <p:spPr>
-          <a:xfrm>
-            <a:off x="960120" y="2304288"/>
-            <a:ext cx="4800600" cy="365760"/>
+          <p:cNvPr id="8" name="Text 6"/>
+          <p:cNvSpPr txBox="1"/>
+          <p:nvPr/>
+        </p:nvSpPr>
+        <p:spPr>
+          <a:xfrm>
+            <a:off x="1417320" y="2459736"/>
+            <a:ext cx="4343400" cy="365760"/>
           </a:xfrm>
           <a:prstGeom prst="rect">
             <a:avLst/>
@@ -1932,57 +1993,101 @@
       </p:sp>
       <p:sp>
         <p:nvSpPr>
-          <p:cNvPr id="7" name="Shape 5"/>
+          <p:cNvPr id="9" name="Shape 7"/>
           <p:cNvSpPr/>
           <p:nvPr/>
         </p:nvSpPr>
         <p:spPr>
           <a:xfrm>
-            <a:off x="640080" y="3063240"/>
-            <a:ext cx="118872" cy="118872"/>
+            <a:off x="640080" y="3172968"/>
+            <a:ext cx="548640" cy="548640"/>
           </a:xfrm>
           <a:prstGeom prst="rect">
             <a:avLst/>
           </a:prstGeom>
           <a:solidFill>
-            <a:srgbClr val="C6A15B"/>
+            <a:srgbClr val="3C2A1C"/>
           </a:solidFill>
-          <a:ln/>
-        </p:spPr>
-      </p:sp>
-      <p:sp>
-        <p:nvSpPr>
-          <p:cNvPr id="8" name="Text 6"/>
-          <p:cNvSpPr txBox="1"/>
-          <p:nvPr/>
-        </p:nvSpPr>
-        <p:spPr>
-          <a:xfrm>
-            <a:off x="960120" y="2898648"/>
-            <a:ext cx="4800600" cy="365760"/>
-          </a:xfrm>
-          <a:prstGeom prst="rect">
-            <a:avLst/>
-          </a:prstGeom>
-          <a:noFill/>
-          <a:ln/>
-        </p:spPr>
-        <p:txBody>
-          <a:bodyPr wrap="square" lIns="0" tIns="0" rIns="0" bIns="0" rtlCol="0" anchor="ctr"/>
-          <a:lstStyle/>
-          <a:p>
-            <a:pPr indent="0" marL="0">
-              <a:buNone/>
-            </a:pPr>
-            <a:r>
-              <a:rPr lang="en-US" sz="1800" b="1" dirty="0">
-                <a:solidFill>
-                  <a:srgbClr val="EFE6D8"/>
+          <a:ln w="12700">
+            <a:solidFill>
+              <a:srgbClr val="9C7C3F"/>
+            </a:solidFill>
+            <a:prstDash val="solid"/>
+          </a:ln>
+        </p:spPr>
+      </p:sp>
+      <p:sp>
+        <p:nvSpPr>
+          <p:cNvPr id="10" name="Text 8"/>
+          <p:cNvSpPr txBox="1"/>
+          <p:nvPr/>
+        </p:nvSpPr>
+        <p:spPr>
+          <a:xfrm>
+            <a:off x="640080" y="3172968"/>
+            <a:ext cx="548640" cy="548640"/>
+          </a:xfrm>
+          <a:prstGeom prst="rect">
+            <a:avLst/>
+          </a:prstGeom>
+          <a:noFill/>
+          <a:ln/>
+        </p:spPr>
+        <p:txBody>
+          <a:bodyPr wrap="square" lIns="0" tIns="0" rIns="0" bIns="0" rtlCol="0" anchor="ctr"/>
+          <a:lstStyle/>
+          <a:p>
+            <a:pPr algn="ctr" indent="0" marL="0">
+              <a:buNone/>
+            </a:pPr>
+            <a:r>
+              <a:rPr lang="en-US" sz="1500" b="1" dirty="0">
+                <a:solidFill>
+                  <a:srgbClr val="C6A15B"/>
                 </a:solidFill>
                 <a:latin typeface="Cambria" pitchFamily="34" charset="0"/>
                 <a:ea typeface="Cambria" pitchFamily="34" charset="-122"/>
                 <a:cs typeface="Cambria" pitchFamily="34" charset="-120"/>
               </a:rPr>
+              <a:t>02</a:t>
+            </a:r>
+            <a:endParaRPr lang="en-US" sz="1500" dirty="0"/>
+          </a:p>
+        </p:txBody>
+      </p:sp>
+      <p:sp>
+        <p:nvSpPr>
+          <p:cNvPr id="11" name="Text 9"/>
+          <p:cNvSpPr txBox="1"/>
+          <p:nvPr/>
+        </p:nvSpPr>
+        <p:spPr>
+          <a:xfrm>
+            <a:off x="1417320" y="3118104"/>
+            <a:ext cx="4343400" cy="365760"/>
+          </a:xfrm>
+          <a:prstGeom prst="rect">
+            <a:avLst/>
+          </a:prstGeom>
+          <a:noFill/>
+          <a:ln/>
+        </p:spPr>
+        <p:txBody>
+          <a:bodyPr wrap="square" lIns="0" tIns="0" rIns="0" bIns="0" rtlCol="0" anchor="ctr"/>
+          <a:lstStyle/>
+          <a:p>
+            <a:pPr indent="0" marL="0">
+              <a:buNone/>
+            </a:pPr>
+            <a:r>
+              <a:rPr lang="en-US" sz="1800" b="1" dirty="0">
+                <a:solidFill>
+                  <a:srgbClr val="EFE6D8"/>
+                </a:solidFill>
+                <a:latin typeface="Cambria" pitchFamily="34" charset="0"/>
+                <a:ea typeface="Cambria" pitchFamily="34" charset="-122"/>
+                <a:cs typeface="Cambria" pitchFamily="34" charset="-120"/>
+              </a:rPr>
               <a:t>Formato</a:t>
             </a:r>
             <a:endParaRPr lang="en-US" sz="1800" dirty="0"/>
@@ -1991,14 +2096,14 @@
       </p:sp>
       <p:sp>
         <p:nvSpPr>
-          <p:cNvPr id="9" name="Text 7"/>
-          <p:cNvSpPr txBox="1"/>
-          <p:nvPr/>
-        </p:nvSpPr>
-        <p:spPr>
-          <a:xfrm>
-            <a:off x="960120" y="3264408"/>
-            <a:ext cx="4800600" cy="365760"/>
+          <p:cNvPr id="12" name="Text 10"/>
+          <p:cNvSpPr txBox="1"/>
+          <p:nvPr/>
+        </p:nvSpPr>
+        <p:spPr>
+          <a:xfrm>
+            <a:off x="1417320" y="3483864"/>
+            <a:ext cx="4343400" cy="365760"/>
           </a:xfrm>
           <a:prstGeom prst="rect">
             <a:avLst/>
@@ -2030,57 +2135,101 @@
       </p:sp>
       <p:sp>
         <p:nvSpPr>
-          <p:cNvPr id="10" name="Shape 8"/>
+          <p:cNvPr id="13" name="Shape 11"/>
           <p:cNvSpPr/>
           <p:nvPr/>
         </p:nvSpPr>
         <p:spPr>
           <a:xfrm>
-            <a:off x="640080" y="4023360"/>
-            <a:ext cx="118872" cy="118872"/>
+            <a:off x="640080" y="4197096"/>
+            <a:ext cx="548640" cy="548640"/>
           </a:xfrm>
           <a:prstGeom prst="rect">
             <a:avLst/>
           </a:prstGeom>
           <a:solidFill>
-            <a:srgbClr val="C6A15B"/>
+            <a:srgbClr val="3C2A1C"/>
           </a:solidFill>
-          <a:ln/>
-        </p:spPr>
-      </p:sp>
-      <p:sp>
-        <p:nvSpPr>
-          <p:cNvPr id="11" name="Text 9"/>
-          <p:cNvSpPr txBox="1"/>
-          <p:nvPr/>
-        </p:nvSpPr>
-        <p:spPr>
-          <a:xfrm>
-            <a:off x="960120" y="3858768"/>
-            <a:ext cx="4800600" cy="365760"/>
-          </a:xfrm>
-          <a:prstGeom prst="rect">
-            <a:avLst/>
-          </a:prstGeom>
-          <a:noFill/>
-          <a:ln/>
-        </p:spPr>
-        <p:txBody>
-          <a:bodyPr wrap="square" lIns="0" tIns="0" rIns="0" bIns="0" rtlCol="0" anchor="ctr"/>
-          <a:lstStyle/>
-          <a:p>
-            <a:pPr indent="0" marL="0">
-              <a:buNone/>
-            </a:pPr>
-            <a:r>
-              <a:rPr lang="en-US" sz="1800" b="1" dirty="0">
-                <a:solidFill>
-                  <a:srgbClr val="EFE6D8"/>
+          <a:ln w="12700">
+            <a:solidFill>
+              <a:srgbClr val="9C7C3F"/>
+            </a:solidFill>
+            <a:prstDash val="solid"/>
+          </a:ln>
+        </p:spPr>
+      </p:sp>
+      <p:sp>
+        <p:nvSpPr>
+          <p:cNvPr id="14" name="Text 12"/>
+          <p:cNvSpPr txBox="1"/>
+          <p:nvPr/>
+        </p:nvSpPr>
+        <p:spPr>
+          <a:xfrm>
+            <a:off x="640080" y="4197096"/>
+            <a:ext cx="548640" cy="548640"/>
+          </a:xfrm>
+          <a:prstGeom prst="rect">
+            <a:avLst/>
+          </a:prstGeom>
+          <a:noFill/>
+          <a:ln/>
+        </p:spPr>
+        <p:txBody>
+          <a:bodyPr wrap="square" lIns="0" tIns="0" rIns="0" bIns="0" rtlCol="0" anchor="ctr"/>
+          <a:lstStyle/>
+          <a:p>
+            <a:pPr algn="ctr" indent="0" marL="0">
+              <a:buNone/>
+            </a:pPr>
+            <a:r>
+              <a:rPr lang="en-US" sz="1500" b="1" dirty="0">
+                <a:solidFill>
+                  <a:srgbClr val="C6A15B"/>
                 </a:solidFill>
                 <a:latin typeface="Cambria" pitchFamily="34" charset="0"/>
                 <a:ea typeface="Cambria" pitchFamily="34" charset="-122"/>
                 <a:cs typeface="Cambria" pitchFamily="34" charset="-120"/>
               </a:rPr>
+              <a:t>03</a:t>
+            </a:r>
+            <a:endParaRPr lang="en-US" sz="1500" dirty="0"/>
+          </a:p>
+        </p:txBody>
+      </p:sp>
+      <p:sp>
+        <p:nvSpPr>
+          <p:cNvPr id="15" name="Text 13"/>
+          <p:cNvSpPr txBox="1"/>
+          <p:nvPr/>
+        </p:nvSpPr>
+        <p:spPr>
+          <a:xfrm>
+            <a:off x="1417320" y="4142232"/>
+            <a:ext cx="4343400" cy="365760"/>
+          </a:xfrm>
+          <a:prstGeom prst="rect">
+            <a:avLst/>
+          </a:prstGeom>
+          <a:noFill/>
+          <a:ln/>
+        </p:spPr>
+        <p:txBody>
+          <a:bodyPr wrap="square" lIns="0" tIns="0" rIns="0" bIns="0" rtlCol="0" anchor="ctr"/>
+          <a:lstStyle/>
+          <a:p>
+            <a:pPr indent="0" marL="0">
+              <a:buNone/>
+            </a:pPr>
+            <a:r>
+              <a:rPr lang="en-US" sz="1800" b="1" dirty="0">
+                <a:solidFill>
+                  <a:srgbClr val="EFE6D8"/>
+                </a:solidFill>
+                <a:latin typeface="Cambria" pitchFamily="34" charset="0"/>
+                <a:ea typeface="Cambria" pitchFamily="34" charset="-122"/>
+                <a:cs typeface="Cambria" pitchFamily="34" charset="-120"/>
+              </a:rPr>
               <a:t>Acabamento</a:t>
             </a:r>
             <a:endParaRPr lang="en-US" sz="1800" dirty="0"/>
@@ -2089,14 +2238,14 @@
       </p:sp>
       <p:sp>
         <p:nvSpPr>
-          <p:cNvPr id="12" name="Text 10"/>
-          <p:cNvSpPr txBox="1"/>
-          <p:nvPr/>
-        </p:nvSpPr>
-        <p:spPr>
-          <a:xfrm>
-            <a:off x="960120" y="4224528"/>
-            <a:ext cx="4800600" cy="365760"/>
+          <p:cNvPr id="16" name="Text 14"/>
+          <p:cNvSpPr txBox="1"/>
+          <p:nvPr/>
+        </p:nvSpPr>
+        <p:spPr>
+          <a:xfrm>
+            <a:off x="1417320" y="4507992"/>
+            <a:ext cx="4343400" cy="365760"/>
           </a:xfrm>
           <a:prstGeom prst="rect">
             <a:avLst/>
@@ -2128,57 +2277,101 @@
       </p:sp>
       <p:sp>
         <p:nvSpPr>
-          <p:cNvPr id="13" name="Shape 11"/>
+          <p:cNvPr id="17" name="Shape 15"/>
           <p:cNvSpPr/>
           <p:nvPr/>
         </p:nvSpPr>
         <p:spPr>
           <a:xfrm>
-            <a:off x="640080" y="4983480"/>
-            <a:ext cx="118872" cy="118872"/>
+            <a:off x="640080" y="5221224"/>
+            <a:ext cx="548640" cy="548640"/>
           </a:xfrm>
           <a:prstGeom prst="rect">
             <a:avLst/>
           </a:prstGeom>
           <a:solidFill>
-            <a:srgbClr val="C6A15B"/>
+            <a:srgbClr val="3C2A1C"/>
           </a:solidFill>
-          <a:ln/>
-        </p:spPr>
-      </p:sp>
-      <p:sp>
-        <p:nvSpPr>
-          <p:cNvPr id="14" name="Text 12"/>
-          <p:cNvSpPr txBox="1"/>
-          <p:nvPr/>
-        </p:nvSpPr>
-        <p:spPr>
-          <a:xfrm>
-            <a:off x="960120" y="4818888"/>
-            <a:ext cx="4800600" cy="365760"/>
-          </a:xfrm>
-          <a:prstGeom prst="rect">
-            <a:avLst/>
-          </a:prstGeom>
-          <a:noFill/>
-          <a:ln/>
-        </p:spPr>
-        <p:txBody>
-          <a:bodyPr wrap="square" lIns="0" tIns="0" rIns="0" bIns="0" rtlCol="0" anchor="ctr"/>
-          <a:lstStyle/>
-          <a:p>
-            <a:pPr indent="0" marL="0">
-              <a:buNone/>
-            </a:pPr>
-            <a:r>
-              <a:rPr lang="en-US" sz="1800" b="1" dirty="0">
-                <a:solidFill>
-                  <a:srgbClr val="EFE6D8"/>
+          <a:ln w="12700">
+            <a:solidFill>
+              <a:srgbClr val="9C7C3F"/>
+            </a:solidFill>
+            <a:prstDash val="solid"/>
+          </a:ln>
+        </p:spPr>
+      </p:sp>
+      <p:sp>
+        <p:nvSpPr>
+          <p:cNvPr id="18" name="Text 16"/>
+          <p:cNvSpPr txBox="1"/>
+          <p:nvPr/>
+        </p:nvSpPr>
+        <p:spPr>
+          <a:xfrm>
+            <a:off x="640080" y="5221224"/>
+            <a:ext cx="548640" cy="548640"/>
+          </a:xfrm>
+          <a:prstGeom prst="rect">
+            <a:avLst/>
+          </a:prstGeom>
+          <a:noFill/>
+          <a:ln/>
+        </p:spPr>
+        <p:txBody>
+          <a:bodyPr wrap="square" lIns="0" tIns="0" rIns="0" bIns="0" rtlCol="0" anchor="ctr"/>
+          <a:lstStyle/>
+          <a:p>
+            <a:pPr algn="ctr" indent="0" marL="0">
+              <a:buNone/>
+            </a:pPr>
+            <a:r>
+              <a:rPr lang="en-US" sz="1500" b="1" dirty="0">
+                <a:solidFill>
+                  <a:srgbClr val="C6A15B"/>
                 </a:solidFill>
                 <a:latin typeface="Cambria" pitchFamily="34" charset="0"/>
                 <a:ea typeface="Cambria" pitchFamily="34" charset="-122"/>
                 <a:cs typeface="Cambria" pitchFamily="34" charset="-120"/>
               </a:rPr>
+              <a:t>04</a:t>
+            </a:r>
+            <a:endParaRPr lang="en-US" sz="1500" dirty="0"/>
+          </a:p>
+        </p:txBody>
+      </p:sp>
+      <p:sp>
+        <p:nvSpPr>
+          <p:cNvPr id="19" name="Text 17"/>
+          <p:cNvSpPr txBox="1"/>
+          <p:nvPr/>
+        </p:nvSpPr>
+        <p:spPr>
+          <a:xfrm>
+            <a:off x="1417320" y="5166360"/>
+            <a:ext cx="4343400" cy="365760"/>
+          </a:xfrm>
+          <a:prstGeom prst="rect">
+            <a:avLst/>
+          </a:prstGeom>
+          <a:noFill/>
+          <a:ln/>
+        </p:spPr>
+        <p:txBody>
+          <a:bodyPr wrap="square" lIns="0" tIns="0" rIns="0" bIns="0" rtlCol="0" anchor="ctr"/>
+          <a:lstStyle/>
+          <a:p>
+            <a:pPr indent="0" marL="0">
+              <a:buNone/>
+            </a:pPr>
+            <a:r>
+              <a:rPr lang="en-US" sz="1800" b="1" dirty="0">
+                <a:solidFill>
+                  <a:srgbClr val="EFE6D8"/>
+                </a:solidFill>
+                <a:latin typeface="Cambria" pitchFamily="34" charset="0"/>
+                <a:ea typeface="Cambria" pitchFamily="34" charset="-122"/>
+                <a:cs typeface="Cambria" pitchFamily="34" charset="-120"/>
+              </a:rPr>
               <a:t>Tipografia</a:t>
             </a:r>
             <a:endParaRPr lang="en-US" sz="1800" dirty="0"/>
@@ -2187,14 +2380,14 @@
       </p:sp>
       <p:sp>
         <p:nvSpPr>
-          <p:cNvPr id="15" name="Text 13"/>
-          <p:cNvSpPr txBox="1"/>
-          <p:nvPr/>
-        </p:nvSpPr>
-        <p:spPr>
-          <a:xfrm>
-            <a:off x="960120" y="5184648"/>
-            <a:ext cx="4800600" cy="365760"/>
+          <p:cNvPr id="20" name="Text 18"/>
+          <p:cNvSpPr txBox="1"/>
+          <p:nvPr/>
+        </p:nvSpPr>
+        <p:spPr>
+          <a:xfrm>
+            <a:off x="1417320" y="5532120"/>
+            <a:ext cx="4343400" cy="365760"/>
           </a:xfrm>
           <a:prstGeom prst="rect">
             <a:avLst/>
@@ -2226,7 +2419,7 @@
       </p:sp>
       <p:pic>
         <p:nvPicPr>
-          <p:cNvPr id="16" name="Image 0" descr="/root/.claude/uploads/de37aeae-c07f-5401-92c3-714ed4fdd346/79f8e012-image.jpg">    </p:cNvPr>
+          <p:cNvPr id="21" name="Image 0" descr="/root/.claude/uploads/de37aeae-c07f-5401-92c3-714ed4fdd346/79f8e012-image.jpg">    </p:cNvPr>
           <p:cNvPicPr>
             <a:picLocks noChangeAspect="1"/>
           </p:cNvPicPr>
@@ -2249,30 +2442,30 @@
       </p:pic>
       <p:sp>
         <p:nvSpPr>
-          <p:cNvPr id="17" name="Text 14"/>
-          <p:cNvSpPr txBox="1"/>
-          <p:nvPr/>
-        </p:nvSpPr>
-        <p:spPr>
-          <a:xfrm>
-            <a:off x="11274552" y="6400800"/>
-            <a:ext cx="548640" cy="274320"/>
-          </a:xfrm>
-          <a:prstGeom prst="rect">
-            <a:avLst/>
-          </a:prstGeom>
-          <a:noFill/>
-          <a:ln/>
-        </p:spPr>
-        <p:txBody>
-          <a:bodyPr wrap="square" lIns="0" tIns="0" rIns="0" bIns="0" rtlCol="0" anchor="ctr"/>
-          <a:lstStyle/>
-          <a:p>
-            <a:pPr algn="r" indent="0" marL="0">
-              <a:buNone/>
-            </a:pPr>
-            <a:r>
-              <a:rPr lang="en-US" sz="1000" dirty="0">
+          <p:cNvPr id="22" name="Text 19"/>
+          <p:cNvSpPr txBox="1"/>
+          <p:nvPr/>
+        </p:nvSpPr>
+        <p:spPr>
+          <a:xfrm>
+            <a:off x="6172200" y="6419088"/>
+            <a:ext cx="5394960" cy="274320"/>
+          </a:xfrm>
+          <a:prstGeom prst="rect">
+            <a:avLst/>
+          </a:prstGeom>
+          <a:noFill/>
+          <a:ln/>
+        </p:spPr>
+        <p:txBody>
+          <a:bodyPr wrap="square" lIns="0" tIns="0" rIns="0" bIns="0" rtlCol="0" anchor="ctr"/>
+          <a:lstStyle/>
+          <a:p>
+            <a:pPr algn="ctr" indent="0" marL="0">
+              <a:buNone/>
+            </a:pPr>
+            <a:r>
+              <a:rPr lang="en-US" sz="1000" i="1" dirty="0">
                 <a:solidFill>
                   <a:srgbClr val="9C7C3F"/>
                 </a:solidFill>
@@ -2280,6 +2473,45 @@
                 <a:ea typeface="Calibri" pitchFamily="34" charset="-122"/>
                 <a:cs typeface="Calibri" pitchFamily="34" charset="-120"/>
               </a:rPr>
+              <a:t>Caixa-livro · Coleção Origem</a:t>
+            </a:r>
+            <a:endParaRPr lang="en-US" sz="1000" dirty="0"/>
+          </a:p>
+        </p:txBody>
+      </p:sp>
+      <p:sp>
+        <p:nvSpPr>
+          <p:cNvPr id="23" name="Text 20"/>
+          <p:cNvSpPr txBox="1"/>
+          <p:nvPr/>
+        </p:nvSpPr>
+        <p:spPr>
+          <a:xfrm>
+            <a:off x="11274552" y="6400800"/>
+            <a:ext cx="548640" cy="274320"/>
+          </a:xfrm>
+          <a:prstGeom prst="rect">
+            <a:avLst/>
+          </a:prstGeom>
+          <a:noFill/>
+          <a:ln/>
+        </p:spPr>
+        <p:txBody>
+          <a:bodyPr wrap="square" lIns="0" tIns="0" rIns="0" bIns="0" rtlCol="0" anchor="ctr"/>
+          <a:lstStyle/>
+          <a:p>
+            <a:pPr algn="r" indent="0" marL="0">
+              <a:buNone/>
+            </a:pPr>
+            <a:r>
+              <a:rPr lang="en-US" sz="1000" dirty="0">
+                <a:solidFill>
+                  <a:srgbClr val="9C7C3F"/>
+                </a:solidFill>
+                <a:latin typeface="Calibri" pitchFamily="34" charset="0"/>
+                <a:ea typeface="Calibri" pitchFamily="34" charset="-122"/>
+                <a:cs typeface="Calibri" pitchFamily="34" charset="-120"/>
+              </a:rPr>
               <a:t>02</a:t>
             </a:r>
             <a:endParaRPr lang="en-US" sz="1000" dirty="0"/>
@@ -2288,7 +2520,7 @@
       </p:sp>
       <p:sp>
         <p:nvSpPr>
-          <p:cNvPr id="18" name="Text 15"/>
+          <p:cNvPr id="24" name="Text 21"/>
           <p:cNvSpPr txBox="1"/>
           <p:nvPr/>
         </p:nvSpPr>
@@ -5713,29 +5945,7 @@
       </p:pic>
       <p:sp>
         <p:nvSpPr>
-          <p:cNvPr id="3" name="Shape 0"/>
-          <p:cNvSpPr/>
-          <p:nvPr/>
-        </p:nvSpPr>
-        <p:spPr>
-          <a:xfrm>
-            <a:off x="4892040" y="0"/>
-            <a:ext cx="411480" cy="6858000"/>
-          </a:xfrm>
-          <a:prstGeom prst="rect">
-            <a:avLst/>
-          </a:prstGeom>
-          <a:solidFill>
-            <a:srgbClr val="17110D">
-              <a:alpha val="85000"/>
-            </a:srgbClr>
-          </a:solidFill>
-          <a:ln/>
-        </p:spPr>
-      </p:sp>
-      <p:sp>
-        <p:nvSpPr>
-          <p:cNvPr id="4" name="Text 1"/>
+          <p:cNvPr id="3" name="Text 0"/>
           <p:cNvSpPr txBox="1"/>
           <p:nvPr/>
         </p:nvSpPr>
@@ -5774,7 +5984,7 @@
       </p:sp>
       <p:sp>
         <p:nvSpPr>
-          <p:cNvPr id="5" name="Text 2"/>
+          <p:cNvPr id="4" name="Text 1"/>
           <p:cNvSpPr txBox="1"/>
           <p:nvPr/>
         </p:nvSpPr>
@@ -5856,7 +6066,7 @@
       </p:sp>
       <p:sp>
         <p:nvSpPr>
-          <p:cNvPr id="6" name="Text 3"/>
+          <p:cNvPr id="5" name="Text 2"/>
           <p:cNvSpPr txBox="1"/>
           <p:nvPr/>
         </p:nvSpPr>
@@ -5918,7 +6128,7 @@
       </p:sp>
       <p:sp>
         <p:nvSpPr>
-          <p:cNvPr id="7" name="Text 4"/>
+          <p:cNvPr id="6" name="Text 3"/>
           <p:cNvSpPr txBox="1"/>
           <p:nvPr/>
         </p:nvSpPr>

</xml_diff>